<commit_message>
HACK-082 (1/2): staff audit re-run with the v2 business conversion and sensitivity (4.5 and 6.5 runs per season, was 3.8/5.5); paper, deck, one-pager and Q&A updated to the v2 business scale (8.68e-4 runs per point, +10 Stuff+ = 1.51 wins, was 1.26); 'escala v1' caveats removed. Recruiting thresholds wait for HACK-083
</commit_message>
<xml_diff>
--- a/demo/deck/deck.pptx
+++ b/demo/deck/deck.pptx
@@ -1191,7 +1191,7 @@
           </a:p>
           <a:p>
             <a:r>
-              <a:t>Fuentes: reports/business_value/runs_per_win.csv; reports/business_value/gm_example.csv · escala de Stuff+ medida con v1.</a:t>
+              <a:t>Fuentes: reports/business_value/runs_per_win.csv; reports/business_value/gm_example.csv · puntos de Stuff+ v2 fuera de pliegue.</a:t>
             </a:r>
           </a:p>
         </p:txBody>
@@ -8610,7 +8610,7 @@
               </a:defRPr>
             </a:pPr>
             <a:r>
-              <a:t>5.5 carreras</a:t>
+              <a:t>6.5 carreras</a:t>
             </a:r>
           </a:p>
         </p:txBody>
@@ -8646,7 +8646,7 @@
               </a:defRPr>
             </a:pPr>
             <a:r>
-              <a:t>0.38 victorias por temporada</a:t>
+              <a:t>0.46 victorias por temporada</a:t>
             </a:r>
           </a:p>
         </p:txBody>
@@ -8682,7 +8682,7 @@
               </a:defRPr>
             </a:pPr>
             <a:r>
-              <a:t>Mezcla 4.3 · aperturas 1.2</a:t>
+              <a:t>Mezcla 5.2 · aperturas 1.4</a:t>
             </a:r>
           </a:p>
         </p:txBody>
@@ -8754,7 +8754,7 @@
               </a:defRPr>
             </a:pPr>
             <a:r>
-              <a:t>3.8 carreras</a:t>
+              <a:t>4.5 carreras</a:t>
             </a:r>
           </a:p>
         </p:txBody>
@@ -8790,7 +8790,7 @@
               </a:defRPr>
             </a:pPr>
             <a:r>
-              <a:t>0.26 victorias por temporada</a:t>
+              <a:t>0.32 victorias por temporada</a:t>
             </a:r>
           </a:p>
         </p:txBody>
@@ -8826,7 +8826,7 @@
               </a:defRPr>
             </a:pPr>
             <a:r>
-              <a:t>Mezcla 2.0 · aperturas 1.8</a:t>
+              <a:t>Mezcla 2.3 · aperturas 2.2</a:t>
             </a:r>
           </a:p>
         </p:txBody>
@@ -9422,7 +9422,7 @@
               </a:defRPr>
             </a:pPr>
             <a:r>
-              <a:t>reports/business_value/runs_per_win.csv; reports/business_value/gm_example.csv · escala de Stuff+ medida con v1.</a:t>
+              <a:t>reports/business_value/runs_per_win.csv; reports/business_value/gm_example.csv · puntos de Stuff+ v2 fuera de pliegue.</a:t>
             </a:r>
           </a:p>
         </p:txBody>
@@ -9710,7 +9710,7 @@
               </a:defRPr>
             </a:pPr>
             <a:r>
-              <a:t>1.26</a:t>
+              <a:t>1.51</a:t>
             </a:r>
           </a:p>
         </p:txBody>
@@ -9818,7 +9818,7 @@
               </a:defRPr>
             </a:pPr>
             <a:r>
-              <a:t>+10 puntos en 2,500 lanzamientos = 18.1 carreras (escenario).</a:t>
+              <a:t>+10 puntos en 2,500 lanzamientos = 21.7 carreras (escenario).</a:t>
             </a:r>
           </a:p>
         </p:txBody>

</xml_diff>

<commit_message>
HACK-082 (2/2): memo rebuilt with the v2 ideal profile (HACK-083 CSVs) and v2 business scale; paper recruiting thresholds to v2 (IVB 21.1 -> 5.8, extension -11.0/-15.3, VAA -12.4/-14.1, ride vs sweeper 7.2 runs per 1,000); deck uses the HACK-051 Playwright screenshots; PDF rebuilt (9 pages)
</commit_message>
<xml_diff>
--- a/demo/deck/deck.pptx
+++ b/demo/deck/deck.pptx
@@ -1116,7 +1116,7 @@
           </a:p>
           <a:p>
             <a:r>
-              <a:t>Fuentes: Capturas del simulador 3D y del explicador de física (web/, build de HACK-045 y HACK-072).</a:t>
+              <a:t>Fuentes: Capturas del simulador 3D y del explicador de física (Playwright, web/e2e/screenshots, HACK-051).</a:t>
             </a:r>
           </a:p>
         </p:txBody>
@@ -9082,7 +9082,7 @@
               </a:defRPr>
             </a:pPr>
             <a:r>
-              <a:t>Capturas del simulador 3D y del explicador de física (web/, build de HACK-045 y HACK-072).</a:t>
+              <a:t>Capturas del simulador 3D y del explicador de física (Playwright, web/e2e/screenshots, HACK-051).</a:t>
             </a:r>
           </a:p>
         </p:txBody>

</xml_diff>